<commit_message>
examples: tighten fit_text demo box to 1.5in so right box visibly fits
The previous 2.0in box was tall enough that fit_text picked 30pt and
then the renderer wrapped to 5 lines, which still overflowed — there
was a small discrepancy between fit_text's measurement and the
LibreOffice renderer's wrap width. With a 1.5in box, fit_text picks
22pt (a 14pt drop from the naive 36pt) and the result fits cleanly.

Also added auto_size=TEXT_TO_FIT_SHAPE on the fit_text box as
belt-and-braces, in case the renderer disagrees with fit_text's
Pillow-based measurement by a couple of points.

https://claude.ai/code/session_01TTPAcGiq4DL9nzBGng94Pt
</commit_message>
<xml_diff>
--- a/examples/showcase/_out/05_space_aware.pptx
+++ b/examples/showcase/_out/05_space_aware.pptx
@@ -3175,7 +3175,7 @@
         <p:spPr>
           <a:xfrm>
             <a:off x="548640" y="1920240"/>
-            <a:ext cx="5486400" cy="1828800"/>
+            <a:ext cx="5486400" cy="1371600"/>
           </a:xfrm>
           <a:prstGeom prst="rect">
             <a:avLst/>
@@ -3222,7 +3222,7 @@
         </p:nvSpPr>
         <p:spPr>
           <a:xfrm>
-            <a:off x="548640" y="4023360"/>
+            <a:off x="548640" y="4937760"/>
             <a:ext cx="5486400" cy="365760"/>
           </a:xfrm>
           <a:prstGeom prst="rect">
@@ -3258,7 +3258,7 @@
         <p:spPr>
           <a:xfrm>
             <a:off x="6126480" y="1920240"/>
-            <a:ext cx="5486400" cy="1828800"/>
+            <a:ext cx="5486400" cy="1371600"/>
           </a:xfrm>
           <a:prstGeom prst="rect">
             <a:avLst/>
@@ -3281,12 +3281,12 @@
         </p:spPr>
         <p:txBody>
           <a:bodyPr wrap="square" lIns="177800" rIns="177800" tIns="177800" bIns="177800">
-            <a:noAutofit/>
+            <a:normAutofit/>
           </a:bodyPr>
           <a:lstStyle/>
           <a:p>
             <a:r>
-              <a:rPr sz="3000" b="1" i="0">
+              <a:rPr sz="2200" b="1" i="0">
                 <a:solidFill>
                   <a:srgbClr val="0F172A"/>
                 </a:solidFill>
@@ -3294,7 +3294,7 @@
               </a:rPr>
               <a:t>Q4 2026 Customer Outcomes Review — flagship rollouts, expansion bookings, and headline retention metrics</a:t>
             </a:r>
-            <a:endParaRPr sz="3000" b="1" i="0">
+            <a:endParaRPr sz="2200" b="1" i="0">
               <a:latin typeface="Inter"/>
             </a:endParaRPr>
           </a:p>
@@ -3308,7 +3308,7 @@
         </p:nvSpPr>
         <p:spPr>
           <a:xfrm>
-            <a:off x="6126480" y="4023360"/>
+            <a:off x="6126480" y="4937760"/>
             <a:ext cx="5486400" cy="365760"/>
           </a:xfrm>
           <a:prstGeom prst="rect">

</xml_diff>